<commit_message>
docs(mira): actualizar referencias tras cambio de identidad Git
</commit_message>
<xml_diff>
--- a/entrega/MIRA-Entrega2.pptx
+++ b/entrega/MIRA-Entrega2.pptx
@@ -2,25 +2,25 @@
 <file path=ppt/presentation.xml><?xml version="1.0" encoding="utf-8"?>
 <p:presentation xmlns:p="http://schemas.openxmlformats.org/presentationml/2006/main">
   <p:sldMasterIdLst>
-    <p:sldMasterId xmlns:r="http://schemas.openxmlformats.org/officeDocument/2006/relationships" id="2147483648" r:id="R98b982a1ecd746dd"/>
+    <p:sldMasterId xmlns:r="http://schemas.openxmlformats.org/officeDocument/2006/relationships" id="2147483648" r:id="Reb0195af543b490d"/>
   </p:sldMasterIdLst>
   <p:notesMasterIdLst>
-    <p:notesMasterId xmlns:r="http://schemas.openxmlformats.org/officeDocument/2006/relationships" r:id="Rf6d53986bc8e4d26"/>
+    <p:notesMasterId xmlns:r="http://schemas.openxmlformats.org/officeDocument/2006/relationships" r:id="R38b89d967253450a"/>
   </p:notesMasterIdLst>
   <p:sldIdLst>
-    <p:sldId xmlns:r="http://schemas.openxmlformats.org/officeDocument/2006/relationships" id="256" r:id="R2ed478eaba174fb8"/>
-    <p:sldId xmlns:r="http://schemas.openxmlformats.org/officeDocument/2006/relationships" id="257" r:id="R514a9faa638d498e"/>
-    <p:sldId xmlns:r="http://schemas.openxmlformats.org/officeDocument/2006/relationships" id="258" r:id="R6e99d312def64f84"/>
-    <p:sldId xmlns:r="http://schemas.openxmlformats.org/officeDocument/2006/relationships" id="259" r:id="R5e770e08a7cb4948"/>
-    <p:sldId xmlns:r="http://schemas.openxmlformats.org/officeDocument/2006/relationships" id="260" r:id="R296202c0ba3d4d2c"/>
-    <p:sldId xmlns:r="http://schemas.openxmlformats.org/officeDocument/2006/relationships" id="261" r:id="Rc0e6da8c24b84170"/>
-    <p:sldId xmlns:r="http://schemas.openxmlformats.org/officeDocument/2006/relationships" id="262" r:id="R288652822c6e44b9"/>
-    <p:sldId xmlns:r="http://schemas.openxmlformats.org/officeDocument/2006/relationships" id="263" r:id="Rdfe98b77af80427d"/>
-    <p:sldId xmlns:r="http://schemas.openxmlformats.org/officeDocument/2006/relationships" id="264" r:id="Rf1e9301daf654c4a"/>
-    <p:sldId xmlns:r="http://schemas.openxmlformats.org/officeDocument/2006/relationships" id="265" r:id="Raeaeb096caba4de1"/>
-    <p:sldId xmlns:r="http://schemas.openxmlformats.org/officeDocument/2006/relationships" id="266" r:id="R2a6e93fe2a7a4aa7"/>
-    <p:sldId xmlns:r="http://schemas.openxmlformats.org/officeDocument/2006/relationships" id="267" r:id="R4947beb6d7704925"/>
-    <p:sldId xmlns:r="http://schemas.openxmlformats.org/officeDocument/2006/relationships" id="268" r:id="R98a495b4e2c84be5"/>
+    <p:sldId xmlns:r="http://schemas.openxmlformats.org/officeDocument/2006/relationships" id="256" r:id="Rf449e946eec34c7d"/>
+    <p:sldId xmlns:r="http://schemas.openxmlformats.org/officeDocument/2006/relationships" id="257" r:id="R0937a2f047b74176"/>
+    <p:sldId xmlns:r="http://schemas.openxmlformats.org/officeDocument/2006/relationships" id="258" r:id="R5a131cc3bc774d3e"/>
+    <p:sldId xmlns:r="http://schemas.openxmlformats.org/officeDocument/2006/relationships" id="259" r:id="R7624dfe664134a4f"/>
+    <p:sldId xmlns:r="http://schemas.openxmlformats.org/officeDocument/2006/relationships" id="260" r:id="R95195c627179493f"/>
+    <p:sldId xmlns:r="http://schemas.openxmlformats.org/officeDocument/2006/relationships" id="261" r:id="R3d9c6c1965e546ee"/>
+    <p:sldId xmlns:r="http://schemas.openxmlformats.org/officeDocument/2006/relationships" id="262" r:id="R5ed2c3785f0b4ebd"/>
+    <p:sldId xmlns:r="http://schemas.openxmlformats.org/officeDocument/2006/relationships" id="263" r:id="Rb3f15af85d804790"/>
+    <p:sldId xmlns:r="http://schemas.openxmlformats.org/officeDocument/2006/relationships" id="264" r:id="R3baf27cbdaf848dd"/>
+    <p:sldId xmlns:r="http://schemas.openxmlformats.org/officeDocument/2006/relationships" id="265" r:id="Ra94829c0f4084b7b"/>
+    <p:sldId xmlns:r="http://schemas.openxmlformats.org/officeDocument/2006/relationships" id="266" r:id="R01f2a2e82935423a"/>
+    <p:sldId xmlns:r="http://schemas.openxmlformats.org/officeDocument/2006/relationships" id="267" r:id="R17cc1fc1639c466d"/>
+    <p:sldId xmlns:r="http://schemas.openxmlformats.org/officeDocument/2006/relationships" id="268" r:id="Rc53ab1940d594d3c"/>
   </p:sldIdLst>
   <p:sldSz cx="12192000" cy="6858000"/>
   <p:notesSz cx="6858000" cy="9144000"/>
@@ -664,7 +664,7 @@
           <a:lstStyle xmlns:a="http://schemas.openxmlformats.org/drawingml/2006/main"/>
           <a:p xmlns:a="http://schemas.openxmlformats.org/drawingml/2006/main">
             <a:r>
-              <a:t>Fuente: docs/qa/measurements.json, reproducibility.json y suites. Medición con 100 casos y 3 evidencias, 30 muestras y 30 revisiones. Se informa CPU incluyendo límites del muestreo. Medición actual commit 632dc13; sin brechas de contadores observadas.</a:t>
+              <a:t>Fuente: docs/qa/measurements.json, reproducibility.json y suites. Medición con 100 casos y 3 evidencias, 30 muestras y 30 revisiones. Se informa CPU incluyendo límites del muestreo. Medición actual commit ab745af; sin brechas de contadores observadas.</a:t>
             </a:r>
           </a:p>
         </p:txBody>
@@ -734,7 +734,7 @@
           <a:lstStyle xmlns:a="http://schemas.openxmlformats.org/drawingml/2006/main"/>
           <a:p xmlns:a="http://schemas.openxmlformats.org/drawingml/2006/main">
             <a:r>
-              <a:t>Fuente: docs/qa/actas-pendientes.md y conclusiones del informe. El repo se entrega en main local; BMAD prohíbe auto-push. No declarar aceptación ni publicación remota.</a:t>
+              <a:t>Fuente: docs/qa/actas-pendientes.md y conclusiones del informe. Repositorio publicado en main por autorización del usuario. No declarar aceptación humana pendiente.</a:t>
             </a:r>
           </a:p>
         </p:txBody>
@@ -1362,7 +1362,7 @@
   </p:cSld>
   <p:clrMap bg1="lt1" tx1="dk1" bg2="lt2" tx2="dk2" accent1="accent1" accent2="accent2" accent3="accent3" accent4="accent4" accent5="accent5" accent6="accent6" hlink="hlink" folHlink="folHlink"/>
   <p:sldLayoutIdLst>
-    <p:sldLayoutId xmlns:r="http://schemas.openxmlformats.org/officeDocument/2006/relationships" id="2147483649" r:id="R70cef9d70f144d47"/>
+    <p:sldLayoutId xmlns:r="http://schemas.openxmlformats.org/officeDocument/2006/relationships" id="2147483649" r:id="Rba6a6d7fec2f4255"/>
   </p:sldLayoutIdLst>
   <p:txStyles>
     <p:titleStyle>
@@ -1913,7 +1913,7 @@
           <p:cNvPr id="5" name="title">
             <a:extLst xmlns:a="http://schemas.openxmlformats.org/drawingml/2006/main">
               <a:ext uri="{FF2B5EF4-FFF2-40B4-BE49-F238E27FC236}">
-                <a16:creationId xmlns:a16="http://schemas.microsoft.com/office/drawing/2014/main" id="{E9253707-389B-4A0A-85AF-870C039F1B72}"/>
+                <a16:creationId xmlns:a16="http://schemas.microsoft.com/office/drawing/2014/main" id="{C4192C04-5BDB-44E5-9578-D52A8A3155B5}"/>
               </a:ext>
             </a:extLst>
           </p:cNvPr>
@@ -1970,7 +1970,7 @@
           <p:cNvPr id="2" name="subtitle">
             <a:extLst xmlns:a="http://schemas.openxmlformats.org/drawingml/2006/main">
               <a:ext uri="{FF2B5EF4-FFF2-40B4-BE49-F238E27FC236}">
-                <a16:creationId xmlns:a16="http://schemas.microsoft.com/office/drawing/2014/main" id="{308DAEF0-E227-41EC-93BF-16A677DC4EA2}"/>
+                <a16:creationId xmlns:a16="http://schemas.microsoft.com/office/drawing/2014/main" id="{E23E99E4-F059-4CDE-972C-5F1DF3B0DE13}"/>
               </a:ext>
             </a:extLst>
           </p:cNvPr>
@@ -2027,7 +2027,7 @@
           <p:cNvPr id="3" name="body">
             <a:extLst xmlns:a="http://schemas.openxmlformats.org/drawingml/2006/main">
               <a:ext uri="{FF2B5EF4-FFF2-40B4-BE49-F238E27FC236}">
-                <a16:creationId xmlns:a16="http://schemas.microsoft.com/office/drawing/2014/main" id="{EE413865-BD68-4B10-AAED-4E4D819B51B6}"/>
+                <a16:creationId xmlns:a16="http://schemas.microsoft.com/office/drawing/2014/main" id="{CC4726A7-0C2E-4596-A0FD-CEC59A7FB772}"/>
               </a:ext>
             </a:extLst>
           </p:cNvPr>
@@ -2163,7 +2163,7 @@
           <p:cNvPr id="4" name="page-number">
             <a:extLst xmlns:a="http://schemas.openxmlformats.org/drawingml/2006/main">
               <a:ext uri="{FF2B5EF4-FFF2-40B4-BE49-F238E27FC236}">
-                <a16:creationId xmlns:a16="http://schemas.microsoft.com/office/drawing/2014/main" id="{883D9D9B-6ECD-4B0F-B75A-9CDC30A26AA0}"/>
+                <a16:creationId xmlns:a16="http://schemas.microsoft.com/office/drawing/2014/main" id="{18314129-7422-43DD-B6BA-0D6948B0F043}"/>
               </a:ext>
             </a:extLst>
           </p:cNvPr>
@@ -2218,7 +2218,7 @@
     </p:spTree>
     <p:extLst>
       <p:ext uri="{BB962C8B-B14F-4D97-AF65-F5344CB8AC3E}">
-        <p14:creationId xmlns:p14="http://schemas.microsoft.com/office/powerpoint/2010/main" val="1977375824"/>
+        <p14:creationId xmlns:p14="http://schemas.microsoft.com/office/powerpoint/2010/main" val="1797240439"/>
       </p:ext>
     </p:extLst>
   </p:cSld>
@@ -2249,7 +2249,7 @@
           <p:cNvPr id="5" name="title">
             <a:extLst xmlns:a="http://schemas.openxmlformats.org/drawingml/2006/main">
               <a:ext uri="{FF2B5EF4-FFF2-40B4-BE49-F238E27FC236}">
-                <a16:creationId xmlns:a16="http://schemas.microsoft.com/office/drawing/2014/main" id="{8BDC6FAD-29B3-4BC2-91F2-E3D7186B0410}"/>
+                <a16:creationId xmlns:a16="http://schemas.microsoft.com/office/drawing/2014/main" id="{DAA3446C-CC74-48A6-A89E-98388B3C1387}"/>
               </a:ext>
             </a:extLst>
           </p:cNvPr>
@@ -2546,7 +2546,7 @@
           <p:cNvPr id="3" name="note">
             <a:extLst xmlns:a="http://schemas.openxmlformats.org/drawingml/2006/main">
               <a:ext uri="{FF2B5EF4-FFF2-40B4-BE49-F238E27FC236}">
-                <a16:creationId xmlns:a16="http://schemas.microsoft.com/office/drawing/2014/main" id="{786CEA4D-F7A9-4864-8671-8F271A3FB9FB}"/>
+                <a16:creationId xmlns:a16="http://schemas.microsoft.com/office/drawing/2014/main" id="{5AE6B288-B66E-43C8-9C0D-80F7ABBD480E}"/>
               </a:ext>
             </a:extLst>
           </p:cNvPr>
@@ -2603,7 +2603,7 @@
           <p:cNvPr id="4" name="page-number">
             <a:extLst xmlns:a="http://schemas.openxmlformats.org/drawingml/2006/main">
               <a:ext uri="{FF2B5EF4-FFF2-40B4-BE49-F238E27FC236}">
-                <a16:creationId xmlns:a16="http://schemas.microsoft.com/office/drawing/2014/main" id="{78D78B28-ACFA-4E5A-BFF6-1BBA8EEC4E8B}"/>
+                <a16:creationId xmlns:a16="http://schemas.microsoft.com/office/drawing/2014/main" id="{C64CEE32-D6AB-4D4C-98FA-84A494D2A25D}"/>
               </a:ext>
             </a:extLst>
           </p:cNvPr>
@@ -2658,7 +2658,7 @@
     </p:spTree>
     <p:extLst>
       <p:ext uri="{BB962C8B-B14F-4D97-AF65-F5344CB8AC3E}">
-        <p14:creationId xmlns:p14="http://schemas.microsoft.com/office/powerpoint/2010/main" val="1452500321"/>
+        <p14:creationId xmlns:p14="http://schemas.microsoft.com/office/powerpoint/2010/main" val="2078811546"/>
       </p:ext>
     </p:extLst>
   </p:cSld>
@@ -2689,7 +2689,7 @@
           <p:cNvPr id="5" name="title">
             <a:extLst xmlns:a="http://schemas.openxmlformats.org/drawingml/2006/main">
               <a:ext uri="{FF2B5EF4-FFF2-40B4-BE49-F238E27FC236}">
-                <a16:creationId xmlns:a16="http://schemas.microsoft.com/office/drawing/2014/main" id="{0FC4FEAB-7CF2-44C8-B76F-FBE9AE5E5F62}"/>
+                <a16:creationId xmlns:a16="http://schemas.microsoft.com/office/drawing/2014/main" id="{E02E42E5-0DAE-4177-9C3D-C3402E3439B8}"/>
               </a:ext>
             </a:extLst>
           </p:cNvPr>
@@ -3029,7 +3029,7 @@
           <p:cNvPr id="3" name="note">
             <a:extLst xmlns:a="http://schemas.openxmlformats.org/drawingml/2006/main">
               <a:ext uri="{FF2B5EF4-FFF2-40B4-BE49-F238E27FC236}">
-                <a16:creationId xmlns:a16="http://schemas.microsoft.com/office/drawing/2014/main" id="{2D6DEC58-EDEB-42B3-85DA-B70647674623}"/>
+                <a16:creationId xmlns:a16="http://schemas.microsoft.com/office/drawing/2014/main" id="{982D01F5-E85C-47E0-81B7-A2617FFC5C28}"/>
               </a:ext>
             </a:extLst>
           </p:cNvPr>
@@ -3086,7 +3086,7 @@
           <p:cNvPr id="4" name="page-number">
             <a:extLst xmlns:a="http://schemas.openxmlformats.org/drawingml/2006/main">
               <a:ext uri="{FF2B5EF4-FFF2-40B4-BE49-F238E27FC236}">
-                <a16:creationId xmlns:a16="http://schemas.microsoft.com/office/drawing/2014/main" id="{9C77F5EE-2EB2-4A50-8EBE-1DAA91EC0E0C}"/>
+                <a16:creationId xmlns:a16="http://schemas.microsoft.com/office/drawing/2014/main" id="{A3229A6B-C67A-492A-90EC-1842BDB4EA30}"/>
               </a:ext>
             </a:extLst>
           </p:cNvPr>
@@ -3141,7 +3141,7 @@
     </p:spTree>
     <p:extLst>
       <p:ext uri="{BB962C8B-B14F-4D97-AF65-F5344CB8AC3E}">
-        <p14:creationId xmlns:p14="http://schemas.microsoft.com/office/powerpoint/2010/main" val="2085570121"/>
+        <p14:creationId xmlns:p14="http://schemas.microsoft.com/office/powerpoint/2010/main" val="1641205560"/>
       </p:ext>
     </p:extLst>
   </p:cSld>
@@ -3172,7 +3172,7 @@
           <p:cNvPr id="5" name="title">
             <a:extLst xmlns:a="http://schemas.openxmlformats.org/drawingml/2006/main">
               <a:ext uri="{FF2B5EF4-FFF2-40B4-BE49-F238E27FC236}">
-                <a16:creationId xmlns:a16="http://schemas.microsoft.com/office/drawing/2014/main" id="{E39DC9B0-E63D-4858-85F2-64CABC7803B2}"/>
+                <a16:creationId xmlns:a16="http://schemas.microsoft.com/office/drawing/2014/main" id="{39A3DD93-ACEE-42EA-AD62-A2647ACECB09}"/>
               </a:ext>
             </a:extLst>
           </p:cNvPr>
@@ -3469,7 +3469,7 @@
           <p:cNvPr id="3" name="note">
             <a:extLst xmlns:a="http://schemas.openxmlformats.org/drawingml/2006/main">
               <a:ext uri="{FF2B5EF4-FFF2-40B4-BE49-F238E27FC236}">
-                <a16:creationId xmlns:a16="http://schemas.microsoft.com/office/drawing/2014/main" id="{51021384-05CF-4F63-AF0B-DB225C3B54F2}"/>
+                <a16:creationId xmlns:a16="http://schemas.microsoft.com/office/drawing/2014/main" id="{1866AD6E-94AA-4317-AA81-95AB751288A7}"/>
               </a:ext>
             </a:extLst>
           </p:cNvPr>
@@ -3526,7 +3526,7 @@
           <p:cNvPr id="4" name="page-number">
             <a:extLst xmlns:a="http://schemas.openxmlformats.org/drawingml/2006/main">
               <a:ext uri="{FF2B5EF4-FFF2-40B4-BE49-F238E27FC236}">
-                <a16:creationId xmlns:a16="http://schemas.microsoft.com/office/drawing/2014/main" id="{2FE82F3C-5698-4A8B-8B91-30DF7C9D2220}"/>
+                <a16:creationId xmlns:a16="http://schemas.microsoft.com/office/drawing/2014/main" id="{26B3076B-A5DE-41DE-8EB1-5D84FCF36C9D}"/>
               </a:ext>
             </a:extLst>
           </p:cNvPr>
@@ -3581,7 +3581,7 @@
     </p:spTree>
     <p:extLst>
       <p:ext uri="{BB962C8B-B14F-4D97-AF65-F5344CB8AC3E}">
-        <p14:creationId xmlns:p14="http://schemas.microsoft.com/office/powerpoint/2010/main" val="806090037"/>
+        <p14:creationId xmlns:p14="http://schemas.microsoft.com/office/powerpoint/2010/main" val="3735860"/>
       </p:ext>
     </p:extLst>
   </p:cSld>
@@ -3612,7 +3612,7 @@
           <p:cNvPr id="4" name="title">
             <a:extLst xmlns:a="http://schemas.openxmlformats.org/drawingml/2006/main">
               <a:ext uri="{FF2B5EF4-FFF2-40B4-BE49-F238E27FC236}">
-                <a16:creationId xmlns:a16="http://schemas.microsoft.com/office/drawing/2014/main" id="{3B5EF2E7-8522-4615-A597-AEE7DC4F2BEF}"/>
+                <a16:creationId xmlns:a16="http://schemas.microsoft.com/office/drawing/2014/main" id="{6D3B716D-459A-47AC-AD6B-FC49D4F85F52}"/>
               </a:ext>
             </a:extLst>
           </p:cNvPr>
@@ -3669,7 +3669,7 @@
           <p:cNvPr id="2" name="body">
             <a:extLst xmlns:a="http://schemas.openxmlformats.org/drawingml/2006/main">
               <a:ext uri="{FF2B5EF4-FFF2-40B4-BE49-F238E27FC236}">
-                <a16:creationId xmlns:a16="http://schemas.microsoft.com/office/drawing/2014/main" id="{C5121ECA-96A6-4A44-823E-8CA6789464AE}"/>
+                <a16:creationId xmlns:a16="http://schemas.microsoft.com/office/drawing/2014/main" id="{DCD46272-01F2-4DC0-A535-35E68361E179}"/>
               </a:ext>
             </a:extLst>
           </p:cNvPr>
@@ -3838,7 +3838,7 @@
           <p:cNvPr id="3" name="page-number">
             <a:extLst xmlns:a="http://schemas.openxmlformats.org/drawingml/2006/main">
               <a:ext uri="{FF2B5EF4-FFF2-40B4-BE49-F238E27FC236}">
-                <a16:creationId xmlns:a16="http://schemas.microsoft.com/office/drawing/2014/main" id="{62FD3337-3546-4BE8-ADF3-3AE7F92DC3EA}"/>
+                <a16:creationId xmlns:a16="http://schemas.microsoft.com/office/drawing/2014/main" id="{C7B19D92-AEBA-43C8-9F71-4D92C677F3E5}"/>
               </a:ext>
             </a:extLst>
           </p:cNvPr>
@@ -3893,7 +3893,7 @@
     </p:spTree>
     <p:extLst>
       <p:ext uri="{BB962C8B-B14F-4D97-AF65-F5344CB8AC3E}">
-        <p14:creationId xmlns:p14="http://schemas.microsoft.com/office/powerpoint/2010/main" val="474291359"/>
+        <p14:creationId xmlns:p14="http://schemas.microsoft.com/office/powerpoint/2010/main" val="1564048248"/>
       </p:ext>
     </p:extLst>
   </p:cSld>
@@ -3924,7 +3924,7 @@
           <p:cNvPr id="7" name="title">
             <a:extLst xmlns:a="http://schemas.openxmlformats.org/drawingml/2006/main">
               <a:ext uri="{FF2B5EF4-FFF2-40B4-BE49-F238E27FC236}">
-                <a16:creationId xmlns:a16="http://schemas.microsoft.com/office/drawing/2014/main" id="{EBF45819-2A81-4B83-94AF-C8031C9E1A28}"/>
+                <a16:creationId xmlns:a16="http://schemas.microsoft.com/office/drawing/2014/main" id="{CB87227D-229A-412F-8362-39F3A273FC14}"/>
               </a:ext>
             </a:extLst>
           </p:cNvPr>
@@ -3981,7 +3981,7 @@
           <p:cNvPr id="2" name="col-title-0">
             <a:extLst xmlns:a="http://schemas.openxmlformats.org/drawingml/2006/main">
               <a:ext uri="{FF2B5EF4-FFF2-40B4-BE49-F238E27FC236}">
-                <a16:creationId xmlns:a16="http://schemas.microsoft.com/office/drawing/2014/main" id="{40376C80-3E08-499E-A65F-4DB96024D6A7}"/>
+                <a16:creationId xmlns:a16="http://schemas.microsoft.com/office/drawing/2014/main" id="{8E339D08-03DF-41ED-8992-571DAB717B08}"/>
               </a:ext>
             </a:extLst>
           </p:cNvPr>
@@ -4038,7 +4038,7 @@
           <p:cNvPr id="3" name="col-body-0">
             <a:extLst xmlns:a="http://schemas.openxmlformats.org/drawingml/2006/main">
               <a:ext uri="{FF2B5EF4-FFF2-40B4-BE49-F238E27FC236}">
-                <a16:creationId xmlns:a16="http://schemas.microsoft.com/office/drawing/2014/main" id="{EF3D7BDE-7D38-471D-B60F-3F18CC61F344}"/>
+                <a16:creationId xmlns:a16="http://schemas.microsoft.com/office/drawing/2014/main" id="{B43BD6D4-634D-441D-A15F-D73455300CA4}"/>
               </a:ext>
             </a:extLst>
           </p:cNvPr>
@@ -4151,7 +4151,7 @@
           <p:cNvPr id="4" name="col-title-1">
             <a:extLst xmlns:a="http://schemas.openxmlformats.org/drawingml/2006/main">
               <a:ext uri="{FF2B5EF4-FFF2-40B4-BE49-F238E27FC236}">
-                <a16:creationId xmlns:a16="http://schemas.microsoft.com/office/drawing/2014/main" id="{754FAF31-ED36-4228-AF5A-15F4139A3D52}"/>
+                <a16:creationId xmlns:a16="http://schemas.microsoft.com/office/drawing/2014/main" id="{E2E6F957-6D51-4C3C-8BE4-C5CFB10D98A5}"/>
               </a:ext>
             </a:extLst>
           </p:cNvPr>
@@ -4208,7 +4208,7 @@
           <p:cNvPr id="5" name="col-body-1">
             <a:extLst xmlns:a="http://schemas.openxmlformats.org/drawingml/2006/main">
               <a:ext uri="{FF2B5EF4-FFF2-40B4-BE49-F238E27FC236}">
-                <a16:creationId xmlns:a16="http://schemas.microsoft.com/office/drawing/2014/main" id="{9E6E512D-1D8C-46A7-85FB-3F5921CFE22A}"/>
+                <a16:creationId xmlns:a16="http://schemas.microsoft.com/office/drawing/2014/main" id="{9BF0B897-9E17-4E07-994D-CB488E159E5C}"/>
               </a:ext>
             </a:extLst>
           </p:cNvPr>
@@ -4321,7 +4321,7 @@
           <p:cNvPr id="6" name="page-number">
             <a:extLst xmlns:a="http://schemas.openxmlformats.org/drawingml/2006/main">
               <a:ext uri="{FF2B5EF4-FFF2-40B4-BE49-F238E27FC236}">
-                <a16:creationId xmlns:a16="http://schemas.microsoft.com/office/drawing/2014/main" id="{CF910B64-89E2-4897-B7A9-16EC80C2733B}"/>
+                <a16:creationId xmlns:a16="http://schemas.microsoft.com/office/drawing/2014/main" id="{CB7C2166-6221-411B-8146-97AB086719AB}"/>
               </a:ext>
             </a:extLst>
           </p:cNvPr>
@@ -4376,7 +4376,7 @@
     </p:spTree>
     <p:extLst>
       <p:ext uri="{BB962C8B-B14F-4D97-AF65-F5344CB8AC3E}">
-        <p14:creationId xmlns:p14="http://schemas.microsoft.com/office/powerpoint/2010/main" val="1083135354"/>
+        <p14:creationId xmlns:p14="http://schemas.microsoft.com/office/powerpoint/2010/main" val="381671017"/>
       </p:ext>
     </p:extLst>
   </p:cSld>
@@ -4407,7 +4407,7 @@
           <p:cNvPr id="5" name="title">
             <a:extLst xmlns:a="http://schemas.openxmlformats.org/drawingml/2006/main">
               <a:ext uri="{FF2B5EF4-FFF2-40B4-BE49-F238E27FC236}">
-                <a16:creationId xmlns:a16="http://schemas.microsoft.com/office/drawing/2014/main" id="{53454CFA-ED92-41E4-98D2-6D067EF64BA9}"/>
+                <a16:creationId xmlns:a16="http://schemas.microsoft.com/office/drawing/2014/main" id="{762491BB-69A5-453E-8BED-5847C2269164}"/>
               </a:ext>
             </a:extLst>
           </p:cNvPr>
@@ -4704,7 +4704,7 @@
           <p:cNvPr id="3" name="note">
             <a:extLst xmlns:a="http://schemas.openxmlformats.org/drawingml/2006/main">
               <a:ext uri="{FF2B5EF4-FFF2-40B4-BE49-F238E27FC236}">
-                <a16:creationId xmlns:a16="http://schemas.microsoft.com/office/drawing/2014/main" id="{0057A43A-3C54-4B61-83C4-F372AC45ABAE}"/>
+                <a16:creationId xmlns:a16="http://schemas.microsoft.com/office/drawing/2014/main" id="{7DB42982-E667-4F64-ACE4-903484838FE8}"/>
               </a:ext>
             </a:extLst>
           </p:cNvPr>
@@ -4761,7 +4761,7 @@
           <p:cNvPr id="4" name="page-number">
             <a:extLst xmlns:a="http://schemas.openxmlformats.org/drawingml/2006/main">
               <a:ext uri="{FF2B5EF4-FFF2-40B4-BE49-F238E27FC236}">
-                <a16:creationId xmlns:a16="http://schemas.microsoft.com/office/drawing/2014/main" id="{D317A804-FB69-4839-9893-5ED306E0FB62}"/>
+                <a16:creationId xmlns:a16="http://schemas.microsoft.com/office/drawing/2014/main" id="{39D7C3AD-8C83-4B07-A3F7-723E9A179BB6}"/>
               </a:ext>
             </a:extLst>
           </p:cNvPr>
@@ -4816,7 +4816,7 @@
     </p:spTree>
     <p:extLst>
       <p:ext uri="{BB962C8B-B14F-4D97-AF65-F5344CB8AC3E}">
-        <p14:creationId xmlns:p14="http://schemas.microsoft.com/office/powerpoint/2010/main" val="311045199"/>
+        <p14:creationId xmlns:p14="http://schemas.microsoft.com/office/powerpoint/2010/main" val="1866885156"/>
       </p:ext>
     </p:extLst>
   </p:cSld>
@@ -4847,7 +4847,7 @@
           <p:cNvPr id="5" name="title">
             <a:extLst xmlns:a="http://schemas.openxmlformats.org/drawingml/2006/main">
               <a:ext uri="{FF2B5EF4-FFF2-40B4-BE49-F238E27FC236}">
-                <a16:creationId xmlns:a16="http://schemas.microsoft.com/office/drawing/2014/main" id="{305396DE-04E5-4F92-AB34-7D29B4AB0A68}"/>
+                <a16:creationId xmlns:a16="http://schemas.microsoft.com/office/drawing/2014/main" id="{D1A3719E-EC37-4B04-BF86-6DFAFF8A4179}"/>
               </a:ext>
             </a:extLst>
           </p:cNvPr>
@@ -5144,7 +5144,7 @@
           <p:cNvPr id="3" name="note">
             <a:extLst xmlns:a="http://schemas.openxmlformats.org/drawingml/2006/main">
               <a:ext uri="{FF2B5EF4-FFF2-40B4-BE49-F238E27FC236}">
-                <a16:creationId xmlns:a16="http://schemas.microsoft.com/office/drawing/2014/main" id="{4823ABBB-DE36-4C91-B174-343519124DE5}"/>
+                <a16:creationId xmlns:a16="http://schemas.microsoft.com/office/drawing/2014/main" id="{82F03AF8-051D-4321-91A6-231247F941FE}"/>
               </a:ext>
             </a:extLst>
           </p:cNvPr>
@@ -5201,7 +5201,7 @@
           <p:cNvPr id="4" name="page-number">
             <a:extLst xmlns:a="http://schemas.openxmlformats.org/drawingml/2006/main">
               <a:ext uri="{FF2B5EF4-FFF2-40B4-BE49-F238E27FC236}">
-                <a16:creationId xmlns:a16="http://schemas.microsoft.com/office/drawing/2014/main" id="{B03C8288-2F03-4E4B-8C90-24FE1765F0BA}"/>
+                <a16:creationId xmlns:a16="http://schemas.microsoft.com/office/drawing/2014/main" id="{D9A2D41E-C0B0-4CBF-86CC-282A3CFD03D9}"/>
               </a:ext>
             </a:extLst>
           </p:cNvPr>
@@ -5256,7 +5256,7 @@
     </p:spTree>
     <p:extLst>
       <p:ext uri="{BB962C8B-B14F-4D97-AF65-F5344CB8AC3E}">
-        <p14:creationId xmlns:p14="http://schemas.microsoft.com/office/powerpoint/2010/main" val="350698125"/>
+        <p14:creationId xmlns:p14="http://schemas.microsoft.com/office/powerpoint/2010/main" val="766020520"/>
       </p:ext>
     </p:extLst>
   </p:cSld>
@@ -5287,7 +5287,7 @@
           <p:cNvPr id="7" name="title">
             <a:extLst xmlns:a="http://schemas.openxmlformats.org/drawingml/2006/main">
               <a:ext uri="{FF2B5EF4-FFF2-40B4-BE49-F238E27FC236}">
-                <a16:creationId xmlns:a16="http://schemas.microsoft.com/office/drawing/2014/main" id="{9596D617-F32D-4EA6-9283-A54F9044E6F0}"/>
+                <a16:creationId xmlns:a16="http://schemas.microsoft.com/office/drawing/2014/main" id="{8386ABD9-6993-4E4C-B163-821D3A44BB73}"/>
               </a:ext>
             </a:extLst>
           </p:cNvPr>
@@ -5344,7 +5344,7 @@
           <p:cNvPr id="2" name="col-title-0">
             <a:extLst xmlns:a="http://schemas.openxmlformats.org/drawingml/2006/main">
               <a:ext uri="{FF2B5EF4-FFF2-40B4-BE49-F238E27FC236}">
-                <a16:creationId xmlns:a16="http://schemas.microsoft.com/office/drawing/2014/main" id="{1D76C639-9AE3-4BC4-B036-0E775512AEFD}"/>
+                <a16:creationId xmlns:a16="http://schemas.microsoft.com/office/drawing/2014/main" id="{5E24CEA9-F732-4C7A-8CC3-D615C62E448A}"/>
               </a:ext>
             </a:extLst>
           </p:cNvPr>
@@ -5401,7 +5401,7 @@
           <p:cNvPr id="3" name="col-body-0">
             <a:extLst xmlns:a="http://schemas.openxmlformats.org/drawingml/2006/main">
               <a:ext uri="{FF2B5EF4-FFF2-40B4-BE49-F238E27FC236}">
-                <a16:creationId xmlns:a16="http://schemas.microsoft.com/office/drawing/2014/main" id="{FD2FDDD4-A9B9-428D-84C2-C451E10DC47D}"/>
+                <a16:creationId xmlns:a16="http://schemas.microsoft.com/office/drawing/2014/main" id="{CED8B2CE-43F0-4D54-B17B-E05959DB2CBB}"/>
               </a:ext>
             </a:extLst>
           </p:cNvPr>
@@ -5514,7 +5514,7 @@
           <p:cNvPr id="4" name="col-title-1">
             <a:extLst xmlns:a="http://schemas.openxmlformats.org/drawingml/2006/main">
               <a:ext uri="{FF2B5EF4-FFF2-40B4-BE49-F238E27FC236}">
-                <a16:creationId xmlns:a16="http://schemas.microsoft.com/office/drawing/2014/main" id="{30F618A0-442E-44DD-8823-2DB0EFB026F9}"/>
+                <a16:creationId xmlns:a16="http://schemas.microsoft.com/office/drawing/2014/main" id="{A065C6FA-0679-4FC0-8967-2EA4A9F41B40}"/>
               </a:ext>
             </a:extLst>
           </p:cNvPr>
@@ -5571,7 +5571,7 @@
           <p:cNvPr id="5" name="col-body-1">
             <a:extLst xmlns:a="http://schemas.openxmlformats.org/drawingml/2006/main">
               <a:ext uri="{FF2B5EF4-FFF2-40B4-BE49-F238E27FC236}">
-                <a16:creationId xmlns:a16="http://schemas.microsoft.com/office/drawing/2014/main" id="{D78A79E9-32FD-4E18-9369-E1A36D5BF2F0}"/>
+                <a16:creationId xmlns:a16="http://schemas.microsoft.com/office/drawing/2014/main" id="{02756417-9C96-4B7A-B5A2-55B630916BF7}"/>
               </a:ext>
             </a:extLst>
           </p:cNvPr>
@@ -5684,7 +5684,7 @@
           <p:cNvPr id="6" name="page-number">
             <a:extLst xmlns:a="http://schemas.openxmlformats.org/drawingml/2006/main">
               <a:ext uri="{FF2B5EF4-FFF2-40B4-BE49-F238E27FC236}">
-                <a16:creationId xmlns:a16="http://schemas.microsoft.com/office/drawing/2014/main" id="{8CFAA440-4B62-4E48-B532-E7564C5C2EC3}"/>
+                <a16:creationId xmlns:a16="http://schemas.microsoft.com/office/drawing/2014/main" id="{882D084E-E1A2-4741-BF67-21DA58634FF8}"/>
               </a:ext>
             </a:extLst>
           </p:cNvPr>
@@ -5739,7 +5739,7 @@
     </p:spTree>
     <p:extLst>
       <p:ext uri="{BB962C8B-B14F-4D97-AF65-F5344CB8AC3E}">
-        <p14:creationId xmlns:p14="http://schemas.microsoft.com/office/powerpoint/2010/main" val="1601190833"/>
+        <p14:creationId xmlns:p14="http://schemas.microsoft.com/office/powerpoint/2010/main" val="1564463166"/>
       </p:ext>
     </p:extLst>
   </p:cSld>
@@ -5770,7 +5770,7 @@
           <p:cNvPr id="5" name="title">
             <a:extLst xmlns:a="http://schemas.openxmlformats.org/drawingml/2006/main">
               <a:ext uri="{FF2B5EF4-FFF2-40B4-BE49-F238E27FC236}">
-                <a16:creationId xmlns:a16="http://schemas.microsoft.com/office/drawing/2014/main" id="{9646C9E1-AB70-4859-9DAF-A202F0BE3FD8}"/>
+                <a16:creationId xmlns:a16="http://schemas.microsoft.com/office/drawing/2014/main" id="{0940F0EB-250D-4B0F-9907-B1C21A927D38}"/>
               </a:ext>
             </a:extLst>
           </p:cNvPr>
@@ -5831,7 +5831,7 @@
           <p:nvPr/>
         </p:nvPicPr>
         <p:blipFill>
-          <a:blip xmlns:r="http://schemas.openxmlformats.org/officeDocument/2006/relationships" xmlns:a="http://schemas.openxmlformats.org/drawingml/2006/main" r:embed="Rc6d3739fc1c64e36"/>
+          <a:blip xmlns:r="http://schemas.openxmlformats.org/officeDocument/2006/relationships" xmlns:a="http://schemas.openxmlformats.org/drawingml/2006/main" r:embed="R2458309cf38c498f"/>
           <a:stretch xmlns:a="http://schemas.openxmlformats.org/drawingml/2006/main"/>
         </p:blipFill>
         <p:spPr>
@@ -5849,7 +5849,7 @@
           <p:cNvPr id="3" name="image-description">
             <a:extLst xmlns:a="http://schemas.openxmlformats.org/drawingml/2006/main">
               <a:ext uri="{FF2B5EF4-FFF2-40B4-BE49-F238E27FC236}">
-                <a16:creationId xmlns:a16="http://schemas.microsoft.com/office/drawing/2014/main" id="{B12A2E40-8BE3-4AD3-A82D-89FCCB0C21C7}"/>
+                <a16:creationId xmlns:a16="http://schemas.microsoft.com/office/drawing/2014/main" id="{D6F73531-4FB1-4B4C-ACB2-4205D7A2C979}"/>
               </a:ext>
             </a:extLst>
           </p:cNvPr>
@@ -6008,7 +6008,7 @@
           <p:cNvPr id="4" name="page-number">
             <a:extLst xmlns:a="http://schemas.openxmlformats.org/drawingml/2006/main">
               <a:ext uri="{FF2B5EF4-FFF2-40B4-BE49-F238E27FC236}">
-                <a16:creationId xmlns:a16="http://schemas.microsoft.com/office/drawing/2014/main" id="{B08A01DA-ECC5-46B3-A951-EF1DE05EAA99}"/>
+                <a16:creationId xmlns:a16="http://schemas.microsoft.com/office/drawing/2014/main" id="{0E16208B-8AE3-42CB-B0B8-EBC572C8694F}"/>
               </a:ext>
             </a:extLst>
           </p:cNvPr>
@@ -6063,7 +6063,7 @@
     </p:spTree>
     <p:extLst>
       <p:ext uri="{BB962C8B-B14F-4D97-AF65-F5344CB8AC3E}">
-        <p14:creationId xmlns:p14="http://schemas.microsoft.com/office/powerpoint/2010/main" val="154779525"/>
+        <p14:creationId xmlns:p14="http://schemas.microsoft.com/office/powerpoint/2010/main" val="266760446"/>
       </p:ext>
     </p:extLst>
   </p:cSld>
@@ -6094,7 +6094,7 @@
           <p:cNvPr id="5" name="title">
             <a:extLst xmlns:a="http://schemas.openxmlformats.org/drawingml/2006/main">
               <a:ext uri="{FF2B5EF4-FFF2-40B4-BE49-F238E27FC236}">
-                <a16:creationId xmlns:a16="http://schemas.microsoft.com/office/drawing/2014/main" id="{AB90939C-063F-443A-BA8F-93F0C0A35BA5}"/>
+                <a16:creationId xmlns:a16="http://schemas.microsoft.com/office/drawing/2014/main" id="{1DD66068-B005-4CDE-92CA-C1D13C347A27}"/>
               </a:ext>
             </a:extLst>
           </p:cNvPr>
@@ -6155,7 +6155,7 @@
           <p:nvPr/>
         </p:nvPicPr>
         <p:blipFill>
-          <a:blip xmlns:r="http://schemas.openxmlformats.org/officeDocument/2006/relationships" xmlns:a="http://schemas.openxmlformats.org/drawingml/2006/main" r:embed="R7e586a4fd58740fc"/>
+          <a:blip xmlns:r="http://schemas.openxmlformats.org/officeDocument/2006/relationships" xmlns:a="http://schemas.openxmlformats.org/drawingml/2006/main" r:embed="R8c127c485f2b4ef8"/>
           <a:stretch xmlns:a="http://schemas.openxmlformats.org/drawingml/2006/main"/>
         </p:blipFill>
         <p:spPr>
@@ -6173,7 +6173,7 @@
           <p:cNvPr id="3" name="image-description">
             <a:extLst xmlns:a="http://schemas.openxmlformats.org/drawingml/2006/main">
               <a:ext uri="{FF2B5EF4-FFF2-40B4-BE49-F238E27FC236}">
-                <a16:creationId xmlns:a16="http://schemas.microsoft.com/office/drawing/2014/main" id="{D035DF4A-7D8A-4218-A8F4-A3F387812E60}"/>
+                <a16:creationId xmlns:a16="http://schemas.microsoft.com/office/drawing/2014/main" id="{3A647289-1400-4123-8C92-8A01C2872DA9}"/>
               </a:ext>
             </a:extLst>
           </p:cNvPr>
@@ -6337,7 +6337,7 @@
           <p:cNvPr id="4" name="page-number">
             <a:extLst xmlns:a="http://schemas.openxmlformats.org/drawingml/2006/main">
               <a:ext uri="{FF2B5EF4-FFF2-40B4-BE49-F238E27FC236}">
-                <a16:creationId xmlns:a16="http://schemas.microsoft.com/office/drawing/2014/main" id="{19113197-10D1-40D6-9481-5DA56EAA43A2}"/>
+                <a16:creationId xmlns:a16="http://schemas.microsoft.com/office/drawing/2014/main" id="{365435E2-C0A9-434F-8E69-50FAFE5FE2CD}"/>
               </a:ext>
             </a:extLst>
           </p:cNvPr>
@@ -6392,7 +6392,7 @@
     </p:spTree>
     <p:extLst>
       <p:ext uri="{BB962C8B-B14F-4D97-AF65-F5344CB8AC3E}">
-        <p14:creationId xmlns:p14="http://schemas.microsoft.com/office/powerpoint/2010/main" val="196839867"/>
+        <p14:creationId xmlns:p14="http://schemas.microsoft.com/office/powerpoint/2010/main" val="944606676"/>
       </p:ext>
     </p:extLst>
   </p:cSld>
@@ -6423,7 +6423,7 @@
           <p:cNvPr id="4" name="title">
             <a:extLst xmlns:a="http://schemas.openxmlformats.org/drawingml/2006/main">
               <a:ext uri="{FF2B5EF4-FFF2-40B4-BE49-F238E27FC236}">
-                <a16:creationId xmlns:a16="http://schemas.microsoft.com/office/drawing/2014/main" id="{8F8BF982-394A-42A5-95B9-6952842EBCDD}"/>
+                <a16:creationId xmlns:a16="http://schemas.microsoft.com/office/drawing/2014/main" id="{A168D171-9C45-45F0-8D69-9A280CB64A35}"/>
               </a:ext>
             </a:extLst>
           </p:cNvPr>
@@ -6480,7 +6480,7 @@
           <p:cNvPr id="2" name="body">
             <a:extLst xmlns:a="http://schemas.openxmlformats.org/drawingml/2006/main">
               <a:ext uri="{FF2B5EF4-FFF2-40B4-BE49-F238E27FC236}">
-                <a16:creationId xmlns:a16="http://schemas.microsoft.com/office/drawing/2014/main" id="{F0F9566B-8287-465A-9024-8BE5D6BD3864}"/>
+                <a16:creationId xmlns:a16="http://schemas.microsoft.com/office/drawing/2014/main" id="{E8B8199D-076A-4C78-B994-02EA144F18EF}"/>
               </a:ext>
             </a:extLst>
           </p:cNvPr>
@@ -6621,7 +6621,7 @@
           <p:cNvPr id="3" name="page-number">
             <a:extLst xmlns:a="http://schemas.openxmlformats.org/drawingml/2006/main">
               <a:ext uri="{FF2B5EF4-FFF2-40B4-BE49-F238E27FC236}">
-                <a16:creationId xmlns:a16="http://schemas.microsoft.com/office/drawing/2014/main" id="{2242216F-A786-4917-98A3-9E6706241203}"/>
+                <a16:creationId xmlns:a16="http://schemas.microsoft.com/office/drawing/2014/main" id="{2FB68D10-BB33-4C48-8C0D-311E623E33CE}"/>
               </a:ext>
             </a:extLst>
           </p:cNvPr>
@@ -6676,7 +6676,7 @@
     </p:spTree>
     <p:extLst>
       <p:ext uri="{BB962C8B-B14F-4D97-AF65-F5344CB8AC3E}">
-        <p14:creationId xmlns:p14="http://schemas.microsoft.com/office/powerpoint/2010/main" val="1751450836"/>
+        <p14:creationId xmlns:p14="http://schemas.microsoft.com/office/powerpoint/2010/main" val="814644237"/>
       </p:ext>
     </p:extLst>
   </p:cSld>
@@ -6707,7 +6707,7 @@
           <p:cNvPr id="5" name="title">
             <a:extLst xmlns:a="http://schemas.openxmlformats.org/drawingml/2006/main">
               <a:ext uri="{FF2B5EF4-FFF2-40B4-BE49-F238E27FC236}">
-                <a16:creationId xmlns:a16="http://schemas.microsoft.com/office/drawing/2014/main" id="{89A4FDDD-F0B0-428F-8AE1-29B16EBBE41B}"/>
+                <a16:creationId xmlns:a16="http://schemas.microsoft.com/office/drawing/2014/main" id="{CE8A56C9-2A3D-4152-9F9F-B40776CFFA33}"/>
               </a:ext>
             </a:extLst>
           </p:cNvPr>
@@ -7004,7 +7004,7 @@
           <p:cNvPr id="3" name="note">
             <a:extLst xmlns:a="http://schemas.openxmlformats.org/drawingml/2006/main">
               <a:ext uri="{FF2B5EF4-FFF2-40B4-BE49-F238E27FC236}">
-                <a16:creationId xmlns:a16="http://schemas.microsoft.com/office/drawing/2014/main" id="{705EC298-3595-4FFF-9A1F-EF806ED08B23}"/>
+                <a16:creationId xmlns:a16="http://schemas.microsoft.com/office/drawing/2014/main" id="{43A13A0A-947A-472C-8742-8F6E5C73C425}"/>
               </a:ext>
             </a:extLst>
           </p:cNvPr>
@@ -7061,7 +7061,7 @@
           <p:cNvPr id="4" name="page-number">
             <a:extLst xmlns:a="http://schemas.openxmlformats.org/drawingml/2006/main">
               <a:ext uri="{FF2B5EF4-FFF2-40B4-BE49-F238E27FC236}">
-                <a16:creationId xmlns:a16="http://schemas.microsoft.com/office/drawing/2014/main" id="{7BBD9B02-654D-46E9-AF53-82AD4B5A0B4D}"/>
+                <a16:creationId xmlns:a16="http://schemas.microsoft.com/office/drawing/2014/main" id="{0FBDC589-C899-491C-AE93-CA1929C41EE5}"/>
               </a:ext>
             </a:extLst>
           </p:cNvPr>
@@ -7116,7 +7116,7 @@
     </p:spTree>
     <p:extLst>
       <p:ext uri="{BB962C8B-B14F-4D97-AF65-F5344CB8AC3E}">
-        <p14:creationId xmlns:p14="http://schemas.microsoft.com/office/powerpoint/2010/main" val="266096599"/>
+        <p14:creationId xmlns:p14="http://schemas.microsoft.com/office/powerpoint/2010/main" val="112159004"/>
       </p:ext>
     </p:extLst>
   </p:cSld>

</xml_diff>